<commit_message>
ACC deck: Inter type, American spelling, plain significance bullets
Co-Authored-By: Claude Opus 5.5 <noreply@anthropic.com>
Claude-Session: https://claude.ai/code/session_01PNdCucn7WBDifAj8PfJZhw
</commit_message>
<xml_diff>
--- a/docs/acc-sim-competition/CoroSim_ACC_Cardio_Sim_Creator.pptx
+++ b/docs/acc-sim-competition/CoroSim_ACC_Cardio_Sim_Creator.pptx
@@ -125,14 +125,14 @@
   <p:extLst>
     <p:ext uri="{521415D9-36F7-43E2-AB2F-B90AF26B5E84}">
       <p14:sectionLst xmlns:p14="http://schemas.microsoft.com/office/powerpoint/2010/main">
-        <p14:section name="Introduction" id="{814eb535-96d3-b021-0e4a-e434fde06b7e}">
+        <p14:section name="Introduction" id="{c851cc1d-64f1-3c98-10cc-d72fb6e8d981}">
           <p14:sldIdLst>
             <p14:sldId id="256"/>
             <p14:sldId id="257"/>
             <p14:sldId id="258"/>
           </p14:sldIdLst>
         </p14:section>
-        <p14:section name="Problem and efficacy" id="{4f7674cd-46fe-4463-9246-178d5af092b8}">
+        <p14:section name="Problem and efficacy" id="{a2cfadd0-dd89-2897-455f-a5a21e6cc365}">
           <p14:sldIdLst>
             <p14:sldId id="259"/>
             <p14:sldId id="260"/>
@@ -145,28 +145,28 @@
             <p14:sldId id="267"/>
           </p14:sldIdLst>
         </p14:section>
-        <p14:section name="Skillsets" id="{a862c2fb-53e3-fc8f-23e7-d7ff7ffd6369}">
+        <p14:section name="Skillsets" id="{ea406870-adac-751d-12f0-372b2d3a03d8}">
           <p14:sldIdLst>
             <p14:sldId id="268"/>
           </p14:sldIdLst>
         </p14:section>
-        <p14:section name="Audience" id="{d5ae07fa-672c-5d82-ad45-5864369ff0c2}">
+        <p14:section name="Audience" id="{4cfac9c9-4b6c-2a64-b0ae-a44030c06301}">
           <p14:sldIdLst>
             <p14:sldId id="269"/>
           </p14:sldIdLst>
         </p14:section>
-        <p14:section name="Assessment" id="{5518fef2-8d40-079b-0bbb-e293f5f5829d}">
+        <p14:section name="Assessment" id="{640a3c1d-2de4-6caf-6a20-792a3e6d6b5e}">
           <p14:sldIdLst>
             <p14:sldId id="270"/>
           </p14:sldIdLst>
         </p14:section>
-        <p14:section name="Significance and integration" id="{23a3bfed-3145-3fd5-12f7-50ec7c1686bf}">
+        <p14:section name="Significance and integration" id="{08641c8c-6796-fc18-12dc-958392f4a5ad}">
           <p14:sldIdLst>
             <p14:sldId id="271"/>
             <p14:sldId id="272"/>
           </p14:sldIdLst>
         </p14:section>
-        <p14:section name="Close" id="{e26b78c9-8028-e01e-1221-555d652cd73c}">
+        <p14:section name="Close" id="{9c64f4d5-294d-9e16-fe7c-7361bbaaafd9}">
           <p14:sldIdLst>
             <p14:sldId id="273"/>
             <p14:sldId id="274"/>
@@ -576,7 +576,7 @@
           <a:p>
             <a:r>
               <a:rPr lang="en-US" dirty="0"/>
-              <a:t>Open on the homepage heart: a weighted Voronoi stipple drawn from the simulator's own coronary tree, coloured by nearness to a vessel. One-sentence pitch: CoroSim lets a learner block any coronary artery and watch the whole patient respond (ECG, rhythm, pressure, reflexes, infarct), then treat them while the muscle is dying.</a:t>
+              <a:t>Open on the homepage heart: a weighted Voronoi stipple drawn from the simulator's own coronary tree, colored by nearness to a vessel. One-sentence pitch: CoroSim lets a learner block any coronary artery and watch the whole patient respond (ECG, rhythm, pressure, reflexes, infarct), then treat them while the muscle is dying.</a:t>
             </a:r>
             <a:endParaRPr lang="en-US" dirty="0"/>
           </a:p>
@@ -1104,7 +1104,7 @@
           <a:p>
             <a:r>
               <a:rPr lang="en-US" dirty="0"/>
-              <a:t>Kirkpatrick levels 1 to 3. Level 1: SUS, realism, confidence pre/post. Level 2: pre/post knowledge test on culprit localisation, rhythm ID and cardiovascular concepts. Level 3: performance trend across repeated daily cases and on course exam items. The planned study is in first-year students at RSOM (Class of 2030); design and timeline to be finalised.</a:t>
+              <a:t>Kirkpatrick levels 1 to 3. Level 1: SUS, realism, confidence pre/post. Level 2: pre/post knowledge test on culprit localization, rhythm ID and cardiovascular concepts. Level 3: performance trend across repeated daily cases and on course exam items. The planned study is in first-year students at RSOM (Class of 2030); design and timeline to be finalized.</a:t>
             </a:r>
             <a:endParaRPr lang="en-US" dirty="0"/>
           </a:p>
@@ -1194,7 +1194,7 @@
               <a:rPr lang="en-US" dirty="0"/>
               <a:t>DRAFT SUBMISSION TEXT (Significance and Seamless Integration):
 Cardiology is learned by connecting cause to effect: an occluded artery to an ischemic wall, that wall to the ST segments, the failing ventricle to the blood pressure, and each treatment to its cost. Most curricula teach these links separately, in lectures, ECG flash cards and occasional mannequin sessions, and learners report the result: low confidence reading ECGs, misconceptions that persist through medical school, and a wish for more practice. CoroSim joins the links. One closed-loop model of the coronary tree, the myocardium, the ECG and the circulation drives every page, so a learner who moves a lesion sees the whole patient change, and then has to treat that patient while the muscle is dying.
-CoroSim is built to fit into what programs already do rather than replace it. It runs free in any browser with no installation, account or license, so it works on a student's phone, a lecture-hall projector or a resident's workstation. Faculty can open a specific patient, tracing or cath case from a link and use it in a first-year physiology small group, flipped-classroom pre-work, clerkship ECG teaching, or internal medicine noon conference and morning report, or embed the link in an LMS module or exam. The daily 'Find the culprit' case gives spaced practice with scored feedback, and an optional AI connection lets Claude or ChatGPT run Socratic rounds on the learner's own patient. CoroSim comes before mannequin and ACLS simulation, so that lab time can go to hands-on skills and teamwork while the reasoning is practised everywhere else.</a:t>
+CoroSim is built to fit into what programs already do rather than replace it. It runs free in any browser with no installation, account or license, so it works on a student's phone, a lecture-hall projector or a resident's workstation. Faculty can open a specific patient, tracing or cath case from a link and use it in a first-year physiology small group, flipped-classroom pre-work, clerkship ECG teaching, or internal medicine noon conference and morning report, or embed the link in an LMS module or exam. The daily 'Find the culprit' case gives spaced practice with scored feedback, and an optional AI connection lets Claude or ChatGPT run Socratic rounds on the learner's own patient. CoroSim comes before mannequin and ACLS simulation, so that lab time can go to hands-on skills and teamwork while the reasoning is practiced everywhere else.</a:t>
             </a:r>
             <a:endParaRPr lang="en-US" dirty="0"/>
           </a:p>
@@ -1810,7 +1810,7 @@
           <a:p>
             <a:r>
               <a:rPr lang="en-US" dirty="0"/>
-              <a:t>Efficacy argument: CoroSim targets mechanism, not memorisation. Because the ECG is computed from the injury current of the ischemic bed, a learner who moves the lesion sees the lead pattern move with it: the cause-and-effect loop that lectures and flash cards cannot give.</a:t>
+              <a:t>Efficacy argument: CoroSim targets mechanism, not memorization. Because the ECG is computed from the injury current of the ischemic bed, a learner who moves the lesion sees the lead pattern move with it: the cause-and-effect loop that lectures and flash cards cannot give.</a:t>
             </a:r>
             <a:endParaRPr lang="en-US" dirty="0"/>
           </a:p>
@@ -2282,7 +2282,7 @@
           <a:lstStyle>
             <a:lvl1pPr algn="l" indent="0" marL="0">
               <a:buNone/>
-              <a:defRPr lang="en-US" sz="5400" b="1" dirty="0">
+              <a:defRPr lang="en-US" sz="5400" b="1" spc="-150" kern="0" dirty="0">
                 <a:solidFill>
                   <a:schemeClr val="bg1"/>
                 </a:solidFill>
@@ -2431,7 +2431,7 @@
           <a:lstStyle>
             <a:lvl1pPr algn="l" indent="0" marL="0">
               <a:buNone/>
-              <a:defRPr lang="en-US" sz="2600" b="1" dirty="0">
+              <a:defRPr lang="en-US" sz="2200" b="1" spc="-50" kern="0" dirty="0">
                 <a:solidFill>
                   <a:schemeClr val="tx1"/>
                 </a:solidFill>
@@ -2442,7 +2442,7 @@
             <a:pPr algn="l" indent="0" marL="0">
               <a:buNone/>
             </a:pPr>
-            <a:endParaRPr lang="en-US" sz="2600" dirty="0"/>
+            <a:endParaRPr lang="en-US" sz="2200" dirty="0"/>
           </a:p>
         </p:txBody>
       </p:sp>
@@ -2963,7 +2963,7 @@
               <a:buNone/>
             </a:pPr>
             <a:r>
-              <a:rPr lang="en-US" sz="5400" b="1" dirty="0">
+              <a:rPr lang="en-US" sz="5400" b="1" spc="-150" kern="0" dirty="0">
                 <a:solidFill>
                   <a:schemeClr val="bg1"/>
                 </a:solidFill>
@@ -3174,14 +3174,14 @@
               <a:buNone/>
             </a:pPr>
             <a:r>
-              <a:rPr lang="en-US" sz="2600" b="1" dirty="0">
+              <a:rPr lang="en-US" sz="2200" b="1" spc="-50" kern="0" dirty="0">
                 <a:solidFill>
                   <a:schemeClr val="tx1"/>
                 </a:solidFill>
               </a:rPr>
               <a:t>A virtual cath lab on the same patient</a:t>
             </a:r>
-            <a:endParaRPr lang="en-US" sz="2600" dirty="0"/>
+            <a:endParaRPr lang="en-US" sz="2200" dirty="0"/>
           </a:p>
         </p:txBody>
       </p:sp>
@@ -3489,14 +3489,14 @@
               <a:buNone/>
             </a:pPr>
             <a:r>
-              <a:rPr lang="en-US" sz="2600" b="1" dirty="0">
+              <a:rPr lang="en-US" sz="2200" b="1" spc="-50" kern="0" dirty="0">
                 <a:solidFill>
                   <a:schemeClr val="tx1"/>
                 </a:solidFill>
               </a:rPr>
               <a:t>Valve and congenital lesions on a closed-loop heart</a:t>
             </a:r>
-            <a:endParaRPr lang="en-US" sz="2600" dirty="0"/>
+            <a:endParaRPr lang="en-US" sz="2200" dirty="0"/>
           </a:p>
         </p:txBody>
       </p:sp>
@@ -3804,14 +3804,14 @@
               <a:buNone/>
             </a:pPr>
             <a:r>
-              <a:rPr lang="en-US" sz="2600" b="1" dirty="0">
+              <a:rPr lang="en-US" sz="2200" b="1" spc="-50" kern="0" dirty="0">
                 <a:solidFill>
                   <a:schemeClr val="tx1"/>
                 </a:solidFill>
               </a:rPr>
               <a:t>From probe position to the echo loop</a:t>
             </a:r>
-            <a:endParaRPr lang="en-US" sz="2600" dirty="0"/>
+            <a:endParaRPr lang="en-US" sz="2200" dirty="0"/>
           </a:p>
         </p:txBody>
       </p:sp>
@@ -4119,14 +4119,14 @@
               <a:buNone/>
             </a:pPr>
             <a:r>
-              <a:rPr lang="en-US" sz="2600" b="1" dirty="0">
+              <a:rPr lang="en-US" sz="2200" b="1" spc="-50" kern="0" dirty="0">
                 <a:solidFill>
                   <a:schemeClr val="tx1"/>
                 </a:solidFill>
               </a:rPr>
-              <a:t>Six skills, and the pages that practise them</a:t>
-            </a:r>
-            <a:endParaRPr lang="en-US" sz="2600" dirty="0"/>
+              <a:t>Six skills, and the pages that practice them</a:t>
+            </a:r>
+            <a:endParaRPr lang="en-US" sz="2200" dirty="0"/>
           </a:p>
         </p:txBody>
       </p:sp>
@@ -4399,7 +4399,7 @@
                   <a:schemeClr val="tx1"/>
                 </a:solidFill>
               </a:rPr>
-              <a:t>Reading the ECG and localising the culprit</a:t>
+              <a:t>Reading the ECG and localizing the culprit</a:t>
             </a:r>
             <a:endParaRPr lang="en-US" sz="1300" dirty="0"/>
           </a:p>
@@ -4782,7 +4782,7 @@
                   <a:schemeClr val="tx1"/>
                 </a:solidFill>
               </a:rPr>
-              <a:t>STEMI and cardiogenic shock management</a:t>
+              <a:t>STEMI and shock management</a:t>
             </a:r>
             <a:endParaRPr lang="en-US" sz="1300" dirty="0"/>
           </a:p>
@@ -5123,7 +5123,7 @@
                   <a:schemeClr val="accent4"/>
                 </a:solidFill>
               </a:rPr>
-              <a:t>practised directly</a:t>
+              <a:t>practiced directly</a:t>
             </a:r>
             <a:endParaRPr lang="en-US" sz="1100" dirty="0"/>
           </a:p>
@@ -5217,7 +5217,7 @@
                   <a:schemeClr val="accent4"/>
                 </a:solidFill>
               </a:rPr>
-              <a:t>Students start with the first three rows; residents add management and invasive reads.</a:t>
+              <a:t>Students start with rows 1–3; residents add the rest.</a:t>
             </a:r>
             <a:endParaRPr lang="en-US" sz="1100" dirty="0"/>
           </a:p>
@@ -5358,14 +5358,14 @@
               <a:buNone/>
             </a:pPr>
             <a:r>
-              <a:rPr lang="en-US" sz="2600" b="1" dirty="0">
+              <a:rPr lang="en-US" sz="2200" b="1" spc="-50" kern="0" dirty="0">
                 <a:solidFill>
                   <a:schemeClr val="tx1"/>
                 </a:solidFill>
               </a:rPr>
               <a:t>Built for medical students and IM residents</a:t>
             </a:r>
-            <a:endParaRPr lang="en-US" sz="2600" dirty="0"/>
+            <a:endParaRPr lang="en-US" sz="2200" dirty="0"/>
           </a:p>
         </p:txBody>
       </p:sp>
@@ -5711,7 +5711,7 @@
                   <a:schemeClr val="tx1"/>
                 </a:solidFill>
               </a:rPr>
-              <a:t>Culprit localisation and STEMI mimics</a:t>
+              <a:t>Culprit localization and STEMI mimics</a:t>
             </a:r>
             <a:endParaRPr lang="en-US" sz="1400" dirty="0"/>
           </a:p>
@@ -5911,14 +5911,14 @@
               <a:buNone/>
             </a:pPr>
             <a:r>
-              <a:rPr lang="en-US" sz="2600" b="1" dirty="0">
+              <a:rPr lang="en-US" sz="2200" b="1" spc="-50" kern="0" dirty="0">
                 <a:solidFill>
                   <a:schemeClr val="tx1"/>
                 </a:solidFill>
               </a:rPr>
               <a:t>Three levels of evaluation, starting with one class</a:t>
             </a:r>
-            <a:endParaRPr lang="en-US" sz="2600" dirty="0"/>
+            <a:endParaRPr lang="en-US" sz="2200" dirty="0"/>
           </a:p>
         </p:txBody>
       </p:sp>
@@ -6228,7 +6228,7 @@
                   <a:schemeClr val="tx1"/>
                 </a:solidFill>
               </a:rPr>
-              <a:t>Pre/post test: culprit localisation from 12-leads</a:t>
+              <a:t>Pre/post test: culprit localization from 12-leads</a:t>
             </a:r>
             <a:endParaRPr lang="en-US" sz="1300" dirty="0"/>
           </a:p>
@@ -6362,7 +6362,7 @@
                 <a:ea typeface="+mj-lt" pitchFamily="34" charset="-122"/>
                 <a:cs typeface="+mj-lt" pitchFamily="34" charset="-120"/>
               </a:rPr>
-              <a:t>Behaviour</a:t>
+              <a:t>Behavior</a:t>
             </a:r>
             <a:endParaRPr lang="en-US" sz="1800" dirty="0"/>
           </a:p>
@@ -6569,7 +6569,7 @@
                   <a:schemeClr val="tx1"/>
                 </a:solidFill>
               </a:rPr>
-              <a:t>CoroSim is being planned for study among first-year students in RSOM's Class of 2030, measuring reaction, learning and behaviour as above. In-app data already scores each case: location error, time to call, the RV call, muscle saved against immediate PCI, time in shock and harmful actions.</a:t>
+              <a:t>CoroSim is being planned for study among first-year students in RSOM's Class of 2030, measuring reaction, learning and behavior as above. In-app data already scores each case: location error, time to call, the RV call, muscle saved against immediate PCI, time in shock and harmful actions.</a:t>
             </a:r>
             <a:endParaRPr lang="en-US" sz="1200" dirty="0"/>
           </a:p>
@@ -6710,360 +6710,164 @@
               <a:buNone/>
             </a:pPr>
             <a:r>
-              <a:rPr lang="en-US" sz="2600" b="1" dirty="0">
+              <a:rPr lang="en-US" sz="2200" b="1" spc="-50" kern="0" dirty="0">
                 <a:solidFill>
                   <a:schemeClr val="tx1"/>
                 </a:solidFill>
               </a:rPr>
               <a:t>Why CoroSim matters in the wider training picture</a:t>
             </a:r>
-            <a:endParaRPr lang="en-US" sz="2600" dirty="0"/>
-          </a:p>
-        </p:txBody>
-      </p:sp>
-      <p:sp>
-        <p:nvSpPr>
-          <p:cNvPr id="4" name="quote card"/>
-          <p:cNvSpPr/>
-          <p:nvPr/>
-        </p:nvSpPr>
-        <p:spPr>
-          <a:xfrm>
-            <a:off x="457200" y="1234440"/>
-            <a:ext cx="3291840" cy="3246120"/>
-          </a:xfrm>
-          <a:prstGeom prst="roundRect">
-            <a:avLst>
-              <a:gd name="adj" fmla="val 2817"/>
-            </a:avLst>
-          </a:prstGeom>
-          <a:solidFill>
-            <a:srgbClr val="000000"/>
-          </a:solidFill>
-          <a:ln/>
-        </p:spPr>
-      </p:sp>
-      <p:sp>
-        <p:nvSpPr>
-          <p:cNvPr id="5" name="Text 3"/>
+            <a:endParaRPr lang="en-US" sz="2200" dirty="0"/>
+          </a:p>
+        </p:txBody>
+      </p:sp>
+      <p:sp>
+        <p:nvSpPr>
+          <p:cNvPr id="4" name="significance points"/>
           <p:cNvSpPr txBox="1"/>
           <p:nvPr/>
         </p:nvSpPr>
         <p:spPr>
           <a:xfrm>
-            <a:off x="731520" y="1463040"/>
-            <a:ext cx="2743200" cy="2788920"/>
-          </a:xfrm>
-          <a:prstGeom prst="rect">
-            <a:avLst/>
-          </a:prstGeom>
-          <a:noFill/>
-          <a:ln/>
-        </p:spPr>
-        <p:txBody>
-          <a:bodyPr wrap="square" lIns="0" tIns="0" rIns="0" bIns="0" rtlCol="0" anchor="ctr"/>
-          <a:lstStyle/>
+            <a:off x="457200" y="1280160"/>
+            <a:ext cx="8229600" cy="3383280"/>
+          </a:xfrm>
+          <a:prstGeom prst="rect">
+            <a:avLst/>
+          </a:prstGeom>
+          <a:noFill/>
+          <a:ln/>
+        </p:spPr>
+        <p:txBody>
+          <a:bodyPr wrap="square" lIns="0" tIns="0" rIns="0" bIns="0" rtlCol="0" anchor="t"/>
+          <a:lstStyle/>
+          <a:p>
+            <a:pPr marL="228600" indent="-228600">
+              <a:buSzPct val="100000"/>
+              <a:buChar char="•"/>
+            </a:pPr>
+            <a:r>
+              <a:rPr lang="en-US" sz="1600" b="1" dirty="0">
+                <a:solidFill>
+                  <a:schemeClr val="tx1"/>
+                </a:solidFill>
+              </a:rPr>
+              <a:t>Cause and effect, made changeable</a:t>
+            </a:r>
+            <a:endParaRPr lang="en-US" sz="1600" dirty="0"/>
+          </a:p>
           <a:p>
             <a:pPr indent="0" marL="0">
-              <a:buNone/>
-            </a:pPr>
-            <a:r>
-              <a:rPr lang="en-US" sz="2000" b="1" i="1" dirty="0">
-                <a:solidFill>
-                  <a:schemeClr val="accent3"/>
-                </a:solidFill>
-                <a:latin typeface="+mj-lt" pitchFamily="34" charset="0"/>
-                <a:ea typeface="+mj-lt" pitchFamily="34" charset="-122"/>
-                <a:cs typeface="+mj-lt" pitchFamily="34" charset="-120"/>
-              </a:rPr>
-              <a:t>Cardiology is learned by seeing cause and effect. CoroSim makes the cause something a learner can change.</a:t>
-            </a:r>
-            <a:endParaRPr lang="en-US" sz="2000" dirty="0"/>
-          </a:p>
-        </p:txBody>
-      </p:sp>
-      <p:sp>
-        <p:nvSpPr>
-          <p:cNvPr id="6" name="dot 1"/>
-          <p:cNvSpPr/>
-          <p:nvPr/>
-        </p:nvSpPr>
-        <p:spPr>
-          <a:xfrm>
-            <a:off x="4069080" y="1307592"/>
-            <a:ext cx="182880" cy="182880"/>
-          </a:xfrm>
-          <a:prstGeom prst="ellipse">
-            <a:avLst/>
-          </a:prstGeom>
-          <a:solidFill>
-            <a:schemeClr val="accent1"/>
-          </a:solidFill>
-          <a:ln/>
-        </p:spPr>
-      </p:sp>
-      <p:sp>
-        <p:nvSpPr>
-          <p:cNvPr id="7" name="Text 5"/>
-          <p:cNvSpPr txBox="1"/>
-          <p:nvPr/>
-        </p:nvSpPr>
-        <p:spPr>
-          <a:xfrm>
-            <a:off x="4434840" y="1234440"/>
-            <a:ext cx="4251960" cy="329184"/>
-          </a:xfrm>
-          <a:prstGeom prst="rect">
-            <a:avLst/>
-          </a:prstGeom>
-          <a:noFill/>
-          <a:ln/>
-        </p:spPr>
-        <p:txBody>
-          <a:bodyPr wrap="square" lIns="0" tIns="0" rIns="0" bIns="0" rtlCol="0" anchor="ctr"/>
-          <a:lstStyle/>
+              <a:spcAft>
+                <a:spcPts val="1000"/>
+              </a:spcAft>
+              <a:buNone/>
+            </a:pPr>
+            <a:r>
+              <a:rPr lang="en-US" sz="1300" dirty="0">
+                <a:solidFill>
+                  <a:schemeClr val="accent4"/>
+                </a:solidFill>
+              </a:rPr>
+              <a:t>Cardiology is learned by seeing cause and effect; CoroSim makes the cause something a learner can change</a:t>
+            </a:r>
+            <a:endParaRPr lang="en-US" sz="1600" dirty="0"/>
+          </a:p>
+          <a:p>
+            <a:pPr marL="228600" indent="-228600">
+              <a:buSzPct val="100000"/>
+              <a:buChar char="•"/>
+            </a:pPr>
+            <a:r>
+              <a:rPr lang="en-US" sz="1600" b="1" dirty="0">
+                <a:solidFill>
+                  <a:schemeClr val="tx1"/>
+                </a:solidFill>
+              </a:rPr>
+              <a:t>One model from physiology to residency</a:t>
+            </a:r>
+            <a:endParaRPr lang="en-US" sz="1600" dirty="0"/>
+          </a:p>
           <a:p>
             <a:pPr indent="0" marL="0">
-              <a:buNone/>
+              <a:spcAft>
+                <a:spcPts val="1000"/>
+              </a:spcAft>
+              <a:buNone/>
+            </a:pPr>
+            <a:r>
+              <a:rPr lang="en-US" sz="1300" dirty="0">
+                <a:solidFill>
+                  <a:schemeClr val="accent4"/>
+                </a:solidFill>
+              </a:rPr>
+              <a:t>The same heart runs from the first-year physiology block to the CCU, so learners build one mental model and keep it</a:t>
+            </a:r>
+            <a:endParaRPr lang="en-US" sz="1600" dirty="0"/>
+          </a:p>
+          <a:p>
+            <a:pPr marL="228600" indent="-228600">
+              <a:buSzPct val="100000"/>
+              <a:buChar char="•"/>
             </a:pPr>
             <a:r>
               <a:rPr lang="en-US" sz="1600" b="1" dirty="0">
                 <a:solidFill>
                   <a:schemeClr val="tx1"/>
                 </a:solidFill>
-                <a:latin typeface="+mj-lt" pitchFamily="34" charset="0"/>
-                <a:ea typeface="+mj-lt" pitchFamily="34" charset="-122"/>
-                <a:cs typeface="+mj-lt" pitchFamily="34" charset="-120"/>
-              </a:rPr>
-              <a:t>One model from physiology to residency</a:t>
+              </a:rPr>
+              <a:t>Practice of rare, high-stakes events</a:t>
             </a:r>
             <a:endParaRPr lang="en-US" sz="1600" dirty="0"/>
           </a:p>
-        </p:txBody>
-      </p:sp>
-      <p:sp>
-        <p:nvSpPr>
-          <p:cNvPr id="8" name="Text 6"/>
-          <p:cNvSpPr txBox="1"/>
-          <p:nvPr/>
-        </p:nvSpPr>
-        <p:spPr>
-          <a:xfrm>
-            <a:off x="4434840" y="1600200"/>
-            <a:ext cx="4251960" cy="640080"/>
-          </a:xfrm>
-          <a:prstGeom prst="rect">
-            <a:avLst/>
-          </a:prstGeom>
-          <a:noFill/>
-          <a:ln/>
-        </p:spPr>
-        <p:txBody>
-          <a:bodyPr wrap="square" lIns="0" tIns="0" rIns="0" bIns="0" rtlCol="0" anchor="t"/>
-          <a:lstStyle/>
           <a:p>
             <a:pPr indent="0" marL="0">
+              <a:spcAft>
+                <a:spcPts val="1000"/>
+              </a:spcAft>
               <a:buNone/>
             </a:pPr>
             <a:r>
               <a:rPr lang="en-US" sz="1300" dirty="0">
                 <a:solidFill>
+                  <a:schemeClr val="accent4"/>
+                </a:solidFill>
+              </a:rPr>
+              <a:t>Unlimited low-stakes repetitions of STEMI, shock and heart block, which rotations cannot guarantee</a:t>
+            </a:r>
+            <a:endParaRPr lang="en-US" sz="1600" dirty="0"/>
+          </a:p>
+          <a:p>
+            <a:pPr marL="228600" indent="-228600">
+              <a:buSzPct val="100000"/>
+              <a:buChar char="•"/>
+            </a:pPr>
+            <a:r>
+              <a:rPr lang="en-US" sz="1600" b="1" dirty="0">
+                <a:solidFill>
                   <a:schemeClr val="tx1"/>
                 </a:solidFill>
               </a:rPr>
-              <a:t>The same heart runs from the first-year physiology block to the CCU, so learners build one mental model and keep it</a:t>
-            </a:r>
-            <a:endParaRPr lang="en-US" sz="1300" dirty="0"/>
-          </a:p>
-        </p:txBody>
-      </p:sp>
-      <p:sp>
-        <p:nvSpPr>
-          <p:cNvPr id="9" name="dot 2"/>
-          <p:cNvSpPr/>
-          <p:nvPr/>
-        </p:nvSpPr>
-        <p:spPr>
-          <a:xfrm>
-            <a:off x="4069080" y="2404872"/>
-            <a:ext cx="182880" cy="182880"/>
-          </a:xfrm>
-          <a:prstGeom prst="ellipse">
-            <a:avLst/>
-          </a:prstGeom>
-          <a:solidFill>
-            <a:schemeClr val="accent1"/>
-          </a:solidFill>
-          <a:ln/>
-        </p:spPr>
-      </p:sp>
-      <p:sp>
-        <p:nvSpPr>
-          <p:cNvPr id="10" name="Text 8"/>
-          <p:cNvSpPr txBox="1"/>
-          <p:nvPr/>
-        </p:nvSpPr>
-        <p:spPr>
-          <a:xfrm>
-            <a:off x="4434840" y="2331720"/>
-            <a:ext cx="4251960" cy="329184"/>
-          </a:xfrm>
-          <a:prstGeom prst="rect">
-            <a:avLst/>
-          </a:prstGeom>
-          <a:noFill/>
-          <a:ln/>
-        </p:spPr>
-        <p:txBody>
-          <a:bodyPr wrap="square" lIns="0" tIns="0" rIns="0" bIns="0" rtlCol="0" anchor="ctr"/>
-          <a:lstStyle/>
+              <a:t>Complements existing simulation</a:t>
+            </a:r>
+            <a:endParaRPr lang="en-US" sz="1600" dirty="0"/>
+          </a:p>
           <a:p>
             <a:pPr indent="0" marL="0">
-              <a:buNone/>
-            </a:pPr>
-            <a:r>
-              <a:rPr lang="en-US" sz="1600" b="1" dirty="0">
-                <a:solidFill>
-                  <a:schemeClr val="tx1"/>
-                </a:solidFill>
-                <a:latin typeface="+mj-lt" pitchFamily="34" charset="0"/>
-                <a:ea typeface="+mj-lt" pitchFamily="34" charset="-122"/>
-                <a:cs typeface="+mj-lt" pitchFamily="34" charset="-120"/>
-              </a:rPr>
-              <a:t>Practice of rare, high-stakes events</a:t>
+              <a:spcAft>
+                <a:spcPts val="1000"/>
+              </a:spcAft>
+              <a:buNone/>
+            </a:pPr>
+            <a:r>
+              <a:rPr lang="en-US" sz="1300" dirty="0">
+                <a:solidFill>
+                  <a:schemeClr val="accent4"/>
+                </a:solidFill>
+              </a:rPr>
+              <a:t>Comes before mannequin and ACLS sessions, so lab time goes to hands-on skills and teamwork</a:t>
             </a:r>
             <a:endParaRPr lang="en-US" sz="1600" dirty="0"/>
-          </a:p>
-        </p:txBody>
-      </p:sp>
-      <p:sp>
-        <p:nvSpPr>
-          <p:cNvPr id="11" name="Text 9"/>
-          <p:cNvSpPr txBox="1"/>
-          <p:nvPr/>
-        </p:nvSpPr>
-        <p:spPr>
-          <a:xfrm>
-            <a:off x="4434840" y="2697480"/>
-            <a:ext cx="4251960" cy="640080"/>
-          </a:xfrm>
-          <a:prstGeom prst="rect">
-            <a:avLst/>
-          </a:prstGeom>
-          <a:noFill/>
-          <a:ln/>
-        </p:spPr>
-        <p:txBody>
-          <a:bodyPr wrap="square" lIns="0" tIns="0" rIns="0" bIns="0" rtlCol="0" anchor="t"/>
-          <a:lstStyle/>
-          <a:p>
-            <a:pPr indent="0" marL="0">
-              <a:buNone/>
-            </a:pPr>
-            <a:r>
-              <a:rPr lang="en-US" sz="1300" dirty="0">
-                <a:solidFill>
-                  <a:schemeClr val="tx1"/>
-                </a:solidFill>
-              </a:rPr>
-              <a:t>Unlimited low-stakes repetitions of STEMI, shock and heart block, which rotations cannot guarantee</a:t>
-            </a:r>
-            <a:endParaRPr lang="en-US" sz="1300" dirty="0"/>
-          </a:p>
-        </p:txBody>
-      </p:sp>
-      <p:sp>
-        <p:nvSpPr>
-          <p:cNvPr id="12" name="dot 3"/>
-          <p:cNvSpPr/>
-          <p:nvPr/>
-        </p:nvSpPr>
-        <p:spPr>
-          <a:xfrm>
-            <a:off x="4069080" y="3502152"/>
-            <a:ext cx="182880" cy="182880"/>
-          </a:xfrm>
-          <a:prstGeom prst="ellipse">
-            <a:avLst/>
-          </a:prstGeom>
-          <a:solidFill>
-            <a:schemeClr val="accent1"/>
-          </a:solidFill>
-          <a:ln/>
-        </p:spPr>
-      </p:sp>
-      <p:sp>
-        <p:nvSpPr>
-          <p:cNvPr id="13" name="Text 11"/>
-          <p:cNvSpPr txBox="1"/>
-          <p:nvPr/>
-        </p:nvSpPr>
-        <p:spPr>
-          <a:xfrm>
-            <a:off x="4434840" y="3429000"/>
-            <a:ext cx="4251960" cy="329184"/>
-          </a:xfrm>
-          <a:prstGeom prst="rect">
-            <a:avLst/>
-          </a:prstGeom>
-          <a:noFill/>
-          <a:ln/>
-        </p:spPr>
-        <p:txBody>
-          <a:bodyPr wrap="square" lIns="0" tIns="0" rIns="0" bIns="0" rtlCol="0" anchor="ctr"/>
-          <a:lstStyle/>
-          <a:p>
-            <a:pPr indent="0" marL="0">
-              <a:buNone/>
-            </a:pPr>
-            <a:r>
-              <a:rPr lang="en-US" sz="1600" b="1" dirty="0">
-                <a:solidFill>
-                  <a:schemeClr val="tx1"/>
-                </a:solidFill>
-                <a:latin typeface="+mj-lt" pitchFamily="34" charset="0"/>
-                <a:ea typeface="+mj-lt" pitchFamily="34" charset="-122"/>
-                <a:cs typeface="+mj-lt" pitchFamily="34" charset="-120"/>
-              </a:rPr>
-              <a:t>Complements existing simulation</a:t>
-            </a:r>
-            <a:endParaRPr lang="en-US" sz="1600" dirty="0"/>
-          </a:p>
-        </p:txBody>
-      </p:sp>
-      <p:sp>
-        <p:nvSpPr>
-          <p:cNvPr id="14" name="Text 12"/>
-          <p:cNvSpPr txBox="1"/>
-          <p:nvPr/>
-        </p:nvSpPr>
-        <p:spPr>
-          <a:xfrm>
-            <a:off x="4434840" y="3794760"/>
-            <a:ext cx="4251960" cy="640080"/>
-          </a:xfrm>
-          <a:prstGeom prst="rect">
-            <a:avLst/>
-          </a:prstGeom>
-          <a:noFill/>
-          <a:ln/>
-        </p:spPr>
-        <p:txBody>
-          <a:bodyPr wrap="square" lIns="0" tIns="0" rIns="0" bIns="0" rtlCol="0" anchor="t"/>
-          <a:lstStyle/>
-          <a:p>
-            <a:pPr indent="0" marL="0">
-              <a:buNone/>
-            </a:pPr>
-            <a:r>
-              <a:rPr lang="en-US" sz="1300" dirty="0">
-                <a:solidFill>
-                  <a:schemeClr val="tx1"/>
-                </a:solidFill>
-              </a:rPr>
-              <a:t>Comes before mannequin and ACLS sessions, so lab time goes to hands and teamwork</a:t>
-            </a:r>
-            <a:endParaRPr lang="en-US" sz="1300" dirty="0"/>
           </a:p>
         </p:txBody>
       </p:sp>
@@ -7202,14 +7006,14 @@
               <a:buNone/>
             </a:pPr>
             <a:r>
-              <a:rPr lang="en-US" sz="2600" b="1" dirty="0">
+              <a:rPr lang="en-US" sz="2200" b="1" spc="-50" kern="0" dirty="0">
                 <a:solidFill>
                   <a:schemeClr val="tx1"/>
                 </a:solidFill>
               </a:rPr>
               <a:t>Fits into the teaching that already happens</a:t>
             </a:r>
-            <a:endParaRPr lang="en-US" sz="2600" dirty="0"/>
+            <a:endParaRPr lang="en-US" sz="2200" dirty="0"/>
           </a:p>
         </p:txBody>
       </p:sp>
@@ -7818,8 +7622,8 @@
         </p:nvSpPr>
         <p:spPr>
           <a:xfrm>
-            <a:off x="4937760" y="1417320"/>
-            <a:ext cx="3840480" cy="640080"/>
+            <a:off x="4846320" y="1417320"/>
+            <a:ext cx="4023360" cy="640080"/>
           </a:xfrm>
           <a:prstGeom prst="rect">
             <a:avLst/>
@@ -7835,7 +7639,7 @@
               <a:buNone/>
             </a:pPr>
             <a:r>
-              <a:rPr lang="en-US" sz="3800" b="1" dirty="0">
+              <a:rPr lang="en-US" sz="3000" b="1" dirty="0">
                 <a:solidFill>
                   <a:schemeClr val="bg1"/>
                 </a:solidFill>
@@ -7845,7 +7649,7 @@
               </a:rPr>
               <a:t>Time is muscle.</a:t>
             </a:r>
-            <a:endParaRPr lang="en-US" sz="3800" dirty="0"/>
+            <a:endParaRPr lang="en-US" sz="3000" dirty="0"/>
           </a:p>
         </p:txBody>
       </p:sp>
@@ -7857,8 +7661,8 @@
         </p:nvSpPr>
         <p:spPr>
           <a:xfrm>
-            <a:off x="4937760" y="2057400"/>
-            <a:ext cx="3840480" cy="640080"/>
+            <a:off x="4846320" y="2057400"/>
+            <a:ext cx="4023360" cy="640080"/>
           </a:xfrm>
           <a:prstGeom prst="rect">
             <a:avLst/>
@@ -7874,7 +7678,7 @@
               <a:buNone/>
             </a:pPr>
             <a:r>
-              <a:rPr lang="en-US" sz="3000" b="1" dirty="0">
+              <a:rPr lang="en-US" sz="2600" b="1" dirty="0">
                 <a:solidFill>
                   <a:schemeClr val="accent2"/>
                 </a:solidFill>
@@ -7884,7 +7688,7 @@
               </a:rPr>
               <a:t>Practice is free.</a:t>
             </a:r>
-            <a:endParaRPr lang="en-US" sz="3000" dirty="0"/>
+            <a:endParaRPr lang="en-US" sz="2600" dirty="0"/>
           </a:p>
         </p:txBody>
       </p:sp>
@@ -8110,14 +7914,14 @@
               <a:buNone/>
             </a:pPr>
             <a:r>
-              <a:rPr lang="en-US" sz="2600" b="1" dirty="0">
+              <a:rPr lang="en-US" sz="2200" b="1" spc="-50" kern="0" dirty="0">
                 <a:solidFill>
                   <a:schemeClr val="tx1"/>
                 </a:solidFill>
               </a:rPr>
               <a:t>Sources</a:t>
             </a:r>
-            <a:endParaRPr lang="en-US" sz="2600" dirty="0"/>
+            <a:endParaRPr lang="en-US" sz="2200" dirty="0"/>
           </a:p>
         </p:txBody>
       </p:sp>
@@ -8430,14 +8234,14 @@
               <a:buNone/>
             </a:pPr>
             <a:r>
-              <a:rPr lang="en-US" sz="2600" b="1" dirty="0">
+              <a:rPr lang="en-US" sz="2200" b="1" spc="-50" kern="0" dirty="0">
                 <a:solidFill>
                   <a:schemeClr val="tx1"/>
                 </a:solidFill>
               </a:rPr>
               <a:t>One simulated patient, six ways to learn from it</a:t>
             </a:r>
-            <a:endParaRPr lang="en-US" sz="2600" dirty="0"/>
+            <a:endParaRPr lang="en-US" sz="2200" dirty="0"/>
           </a:p>
         </p:txBody>
       </p:sp>
@@ -8559,7 +8363,7 @@
               <a:buNone/>
             </a:pPr>
             <a:r>
-              <a:rPr lang="en-US" sz="1600" b="1" dirty="0">
+              <a:rPr lang="en-US" sz="1500" b="1" dirty="0">
                 <a:solidFill>
                   <a:schemeClr val="tx1"/>
                 </a:solidFill>
@@ -8569,7 +8373,7 @@
               </a:rPr>
               <a:t>Six linked pages</a:t>
             </a:r>
-            <a:endParaRPr lang="en-US" sz="1600" dirty="0"/>
+            <a:endParaRPr lang="en-US" sz="1500" dirty="0"/>
           </a:p>
         </p:txBody>
       </p:sp>
@@ -8582,7 +8386,7 @@
         <p:spPr>
           <a:xfrm>
             <a:off x="6126480" y="1581912"/>
-            <a:ext cx="2560320" cy="594360"/>
+            <a:ext cx="2560320" cy="713232"/>
           </a:xfrm>
           <a:prstGeom prst="rect">
             <a:avLst/>
@@ -8598,14 +8402,14 @@
               <a:buNone/>
             </a:pPr>
             <a:r>
-              <a:rPr lang="en-US" sz="1300" dirty="0">
+              <a:rPr lang="en-US" sz="1200" dirty="0">
                 <a:solidFill>
                   <a:schemeClr val="accent4"/>
                 </a:solidFill>
               </a:rPr>
               <a:t>Simulator, daily case, EKG, cath lab, structural and echo, all running the same patient model.</a:t>
             </a:r>
-            <a:endParaRPr lang="en-US" sz="1300" dirty="0"/>
+            <a:endParaRPr lang="en-US" sz="1200" dirty="0"/>
           </a:p>
         </p:txBody>
       </p:sp>
@@ -8617,7 +8421,7 @@
         </p:nvSpPr>
         <p:spPr>
           <a:xfrm>
-            <a:off x="6126480" y="2258568"/>
+            <a:off x="6126480" y="2331720"/>
             <a:ext cx="2560320" cy="320040"/>
           </a:xfrm>
           <a:prstGeom prst="rect">
@@ -8634,7 +8438,7 @@
               <a:buNone/>
             </a:pPr>
             <a:r>
-              <a:rPr lang="en-US" sz="1600" b="1" dirty="0">
+              <a:rPr lang="en-US" sz="1500" b="1" dirty="0">
                 <a:solidFill>
                   <a:schemeClr val="tx1"/>
                 </a:solidFill>
@@ -8642,9 +8446,9 @@
                 <a:ea typeface="+mj-lt" pitchFamily="34" charset="-122"/>
                 <a:cs typeface="+mj-lt" pitchFamily="34" charset="-120"/>
               </a:rPr>
-              <a:t>More than 50 EKG presets</a:t>
-            </a:r>
-            <a:endParaRPr lang="en-US" sz="1600" dirty="0"/>
+              <a:t>50+ EKG presets</a:t>
+            </a:r>
+            <a:endParaRPr lang="en-US" sz="1500" dirty="0"/>
           </a:p>
         </p:txBody>
       </p:sp>
@@ -8656,8 +8460,8 @@
         </p:nvSpPr>
         <p:spPr>
           <a:xfrm>
-            <a:off x="6126480" y="2606040"/>
-            <a:ext cx="2560320" cy="594360"/>
+            <a:off x="6126480" y="2679192"/>
+            <a:ext cx="2560320" cy="713232"/>
           </a:xfrm>
           <a:prstGeom prst="rect">
             <a:avLst/>
@@ -8673,14 +8477,14 @@
               <a:buNone/>
             </a:pPr>
             <a:r>
-              <a:rPr lang="en-US" sz="1300" dirty="0">
+              <a:rPr lang="en-US" sz="1200" dirty="0">
                 <a:solidFill>
                   <a:schemeClr val="accent4"/>
                 </a:solidFill>
               </a:rPr>
               <a:t>Rhythms, blocks, ischemia and STEMI mimics, plus custom tracings on request.</a:t>
             </a:r>
-            <a:endParaRPr lang="en-US" sz="1300" dirty="0"/>
+            <a:endParaRPr lang="en-US" sz="1200" dirty="0"/>
           </a:p>
         </p:txBody>
       </p:sp>
@@ -8692,7 +8496,7 @@
         </p:nvSpPr>
         <p:spPr>
           <a:xfrm>
-            <a:off x="6126480" y="3282696"/>
+            <a:off x="6126480" y="3429000"/>
             <a:ext cx="2560320" cy="320040"/>
           </a:xfrm>
           <a:prstGeom prst="rect">
@@ -8709,7 +8513,7 @@
               <a:buNone/>
             </a:pPr>
             <a:r>
-              <a:rPr lang="en-US" sz="1600" b="1" dirty="0">
+              <a:rPr lang="en-US" sz="1500" b="1" dirty="0">
                 <a:solidFill>
                   <a:schemeClr val="tx1"/>
                 </a:solidFill>
@@ -8719,7 +8523,7 @@
               </a:rPr>
               <a:t>Free in any browser</a:t>
             </a:r>
-            <a:endParaRPr lang="en-US" sz="1600" dirty="0"/>
+            <a:endParaRPr lang="en-US" sz="1500" dirty="0"/>
           </a:p>
         </p:txBody>
       </p:sp>
@@ -8731,8 +8535,8 @@
         </p:nvSpPr>
         <p:spPr>
           <a:xfrm>
-            <a:off x="6126480" y="3630168"/>
-            <a:ext cx="2560320" cy="594360"/>
+            <a:off x="6126480" y="3776472"/>
+            <a:ext cx="2560320" cy="713232"/>
           </a:xfrm>
           <a:prstGeom prst="rect">
             <a:avLst/>
@@ -8748,14 +8552,14 @@
               <a:buNone/>
             </a:pPr>
             <a:r>
-              <a:rPr lang="en-US" sz="1300" dirty="0">
+              <a:rPr lang="en-US" sz="1200" dirty="0">
                 <a:solidFill>
                   <a:schemeClr val="accent4"/>
                 </a:solidFill>
               </a:rPr>
               <a:t>No install, account or license.</a:t>
             </a:r>
-            <a:endParaRPr lang="en-US" sz="1300" dirty="0"/>
+            <a:endParaRPr lang="en-US" sz="1200" dirty="0"/>
           </a:p>
         </p:txBody>
       </p:sp>
@@ -8894,14 +8698,14 @@
               <a:buNone/>
             </a:pPr>
             <a:r>
-              <a:rPr lang="en-US" sz="2600" b="1" dirty="0">
+              <a:rPr lang="en-US" sz="2200" b="1" spc="-50" kern="0" dirty="0">
                 <a:solidFill>
                   <a:schemeClr val="tx1"/>
                 </a:solidFill>
               </a:rPr>
               <a:t>What this submission answers</a:t>
             </a:r>
-            <a:endParaRPr lang="en-US" sz="2600" dirty="0"/>
+            <a:endParaRPr lang="en-US" sz="2200" dirty="0"/>
           </a:p>
         </p:txBody>
       </p:sp>
@@ -9108,7 +8912,7 @@
                   <a:schemeClr val="accent4"/>
                 </a:solidFill>
               </a:rPr>
-              <a:t>Six skills, and which pages practise each</a:t>
+              <a:t>Six skills, and which pages practice each</a:t>
             </a:r>
             <a:endParaRPr lang="en-US" sz="1300" dirty="0"/>
           </a:p>
@@ -9687,14 +9491,14 @@
               <a:buNone/>
             </a:pPr>
             <a:r>
-              <a:rPr lang="en-US" sz="2600" b="1" dirty="0">
+              <a:rPr lang="en-US" sz="2200" b="1" spc="-50" kern="0" dirty="0">
                 <a:solidFill>
                   <a:schemeClr val="tx1"/>
                 </a:solidFill>
               </a:rPr>
               <a:t>Learners want more ECG practice than they get</a:t>
             </a:r>
-            <a:endParaRPr lang="en-US" sz="2600" dirty="0"/>
+            <a:endParaRPr lang="en-US" sz="2200" dirty="0"/>
           </a:p>
         </p:txBody>
       </p:sp>
@@ -10323,14 +10127,14 @@
               <a:buNone/>
             </a:pPr>
             <a:r>
-              <a:rPr lang="en-US" sz="2600" b="1" dirty="0">
+              <a:rPr lang="en-US" sz="2200" b="1" spc="-50" kern="0" dirty="0">
                 <a:solidFill>
                   <a:schemeClr val="tx1"/>
                 </a:solidFill>
               </a:rPr>
               <a:t>Where learning breaks down, and what changes</a:t>
             </a:r>
-            <a:endParaRPr lang="en-US" sz="2600" dirty="0"/>
+            <a:endParaRPr lang="en-US" sz="2200" dirty="0"/>
           </a:p>
         </p:txBody>
       </p:sp>
@@ -10465,7 +10269,7 @@
                   <a:schemeClr val="tx1"/>
                 </a:solidFill>
               </a:rPr>
-              <a:t>ECGs are memorised as patterns, cut off from anatomy</a:t>
+              <a:t>ECGs are memorized as patterns, cut off from anatomy</a:t>
             </a:r>
             <a:endParaRPr lang="en-US" sz="1300" dirty="0"/>
           </a:p>
@@ -10479,7 +10283,7 @@
                   <a:schemeClr val="accent4"/>
                 </a:solidFill>
               </a:rPr>
-              <a:t>Students say past teaching "focused on memorising traces" (Cardoso Pinto 2024)</a:t>
+              <a:t>Students say past teaching "focused on memorizing traces" (Cardoso Pinto 2024)</a:t>
             </a:r>
             <a:endParaRPr lang="en-US" sz="1300" dirty="0"/>
           </a:p>
@@ -10683,7 +10487,7 @@
                   <a:schemeClr val="tx1"/>
                 </a:solidFill>
               </a:rPr>
-              <a:t>STEMI and shock decisions are rarely practised</a:t>
+              <a:t>STEMI and shock decisions are rarely practiced</a:t>
             </a:r>
             <a:endParaRPr lang="en-US" sz="1300" dirty="0"/>
           </a:p>
@@ -10955,14 +10759,14 @@
               <a:buNone/>
             </a:pPr>
             <a:r>
-              <a:rPr lang="en-US" sz="2600" b="1" dirty="0">
+              <a:rPr lang="en-US" sz="2200" b="1" spc="-50" kern="0" dirty="0">
                 <a:solidFill>
                   <a:schemeClr val="tx1"/>
                 </a:solidFill>
               </a:rPr>
               <a:t>Block an artery and watch the patient respond</a:t>
             </a:r>
-            <a:endParaRPr lang="en-US" sz="2600" dirty="0"/>
+            <a:endParaRPr lang="en-US" sz="2200" dirty="0"/>
           </a:p>
         </p:txBody>
       </p:sp>
@@ -11270,14 +11074,14 @@
               <a:buNone/>
             </a:pPr>
             <a:r>
-              <a:rPr lang="en-US" sz="2600" b="1" dirty="0">
+              <a:rPr lang="en-US" sz="2200" b="1" spc="-50" kern="0" dirty="0">
                 <a:solidFill>
                   <a:schemeClr val="tx1"/>
                 </a:solidFill>
               </a:rPr>
               <a:t>Read the 12-lead, then treat the patient</a:t>
             </a:r>
-            <a:endParaRPr lang="en-US" sz="2600" dirty="0"/>
+            <a:endParaRPr lang="en-US" sz="2200" dirty="0"/>
           </a:p>
         </p:txBody>
       </p:sp>
@@ -11408,7 +11212,7 @@
                   <a:schemeClr val="tx1"/>
                 </a:solidFill>
               </a:rPr>
-              <a:t>ST shifts come from each ischemic bed, so the leads point to the artery</a:t>
+              <a:t>ST shifts point to the blocked artery</a:t>
             </a:r>
             <a:endParaRPr lang="en-US" sz="1300" dirty="0"/>
           </a:p>
@@ -11426,7 +11230,7 @@
                   <a:schemeClr val="tx1"/>
                 </a:solidFill>
               </a:rPr>
-              <a:t>Every drug and device has its real cost; warnings name the harm</a:t>
+              <a:t>Each drug and device carries its real cost</a:t>
             </a:r>
             <a:endParaRPr lang="en-US" sz="1300" dirty="0"/>
           </a:p>
@@ -11444,7 +11248,7 @@
                   <a:schemeClr val="tx1"/>
                 </a:solidFill>
               </a:rPr>
-              <a:t>PCI, lysis and CABG arrive after their real delays</a:t>
+              <a:t>PCI, lysis and CABG take their real time</a:t>
             </a:r>
             <a:endParaRPr lang="en-US" sz="1300" dirty="0"/>
           </a:p>
@@ -11678,14 +11482,14 @@
               <a:buNone/>
             </a:pPr>
             <a:r>
-              <a:rPr lang="en-US" sz="2600" b="1" dirty="0">
+              <a:rPr lang="en-US" sz="2200" b="1" spc="-50" kern="0" dirty="0">
                 <a:solidFill>
                   <a:schemeClr val="tx1"/>
                 </a:solidFill>
               </a:rPr>
               <a:t>A daily hidden-lesion case, the same for everyone</a:t>
             </a:r>
-            <a:endParaRPr lang="en-US" sz="2600" dirty="0"/>
+            <a:endParaRPr lang="en-US" sz="2200" dirty="0"/>
           </a:p>
         </p:txBody>
       </p:sp>
@@ -11993,14 +11797,14 @@
               <a:buNone/>
             </a:pPr>
             <a:r>
-              <a:rPr lang="en-US" sz="2600" b="1" dirty="0">
+              <a:rPr lang="en-US" sz="2200" b="1" spc="-50" kern="0" dirty="0">
                 <a:solidFill>
                   <a:schemeClr val="tx1"/>
                 </a:solidFill>
               </a:rPr>
               <a:t>More than 50 tracings, each drawn through a 3D heart</a:t>
             </a:r>
-            <a:endParaRPr lang="en-US" sz="2600" dirty="0"/>
+            <a:endParaRPr lang="en-US" sz="2200" dirty="0"/>
           </a:p>
         </p:txBody>
       </p:sp>
@@ -12269,7 +12073,7 @@
     </a:clrScheme>
     <a:fontScheme name="CoroSim textbook">
       <a:majorFont>
-        <a:latin typeface="Cambria"/>
+        <a:latin typeface="Inter"/>
         <a:ea typeface=""/>
         <a:cs typeface=""/>
         <a:font script="Jpan" typeface="游ゴシック Light"/>
@@ -12321,7 +12125,7 @@
         <a:font script="Tfng" typeface="Ebrima"/>
       </a:majorFont>
       <a:minorFont>
-        <a:latin typeface="Calibri"/>
+        <a:latin typeface="Inter"/>
         <a:ea typeface=""/>
         <a:cs typeface=""/>
         <a:font script="Jpan" typeface="游ゴシック"/>

</xml_diff>